<commit_message>
Presentation + manager questions refreshed to 1-3 July data
Презентация (.pptx/.html) под реальные цифры 1-3 июля (230 диалогов,
бот сам 70%, тиры 74/88/70) + «уже работает на проде» вместо «макет».
Курированная анкета менеджерам из разбора 200 реальных вопросов клиентов
(docs/manager-questions-*.md). Ключевая находка: ~79% первых сообщений —
реклама, которую бот не видит.
</commit_message>
<xml_diff>
--- a/frunze_presentation_build.pptx
+++ b/frunze_presentation_build.pptx
@@ -3328,7 +3328,7 @@
                 </a:solidFill>
                 <a:latin typeface="Arial"/>
               </a:rPr>
-              <a:t>515</a:t>
+              <a:t>230</a:t>
             </a:r>
           </a:p>
         </p:txBody>
@@ -3403,7 +3403,7 @@
                 </a:solidFill>
                 <a:latin typeface="Arial"/>
               </a:rPr>
-              <a:t>98,4%</a:t>
+              <a:t>70%</a:t>
             </a:r>
           </a:p>
         </p:txBody>
@@ -3648,7 +3648,7 @@
         <p:spPr>
           <a:xfrm>
             <a:off x="685800" y="5925312"/>
-            <a:ext cx="8595360" cy="228600"/>
+            <a:ext cx="10058400" cy="228600"/>
           </a:xfrm>
           <a:prstGeom prst="rect">
             <a:avLst/>
@@ -3666,7 +3666,7 @@
                 </a:solidFill>
                 <a:latin typeface="Arial"/>
               </a:rPr>
-              <a:t>Данные из рабочей базы за 24.06–02.07.2026. Панель — макет решения.</a:t>
+              <a:t>Данные из рабочей базы за 1–3 июля 2026. Панель «Покупатели сегодня» уже работает на проде.</a:t>
             </a:r>
           </a:p>
         </p:txBody>
@@ -3828,7 +3828,7 @@
                 <a:gridCol w="3429000"/>
                 <a:gridCol w="3913632"/>
               </a:tblGrid>
-              <a:tr h="325858">
+              <a:tr h="716889">
                 <a:tc>
                   <a:txBody>
                     <a:bodyPr wrap="square" anchor="ctr"/>
@@ -3865,7 +3865,7 @@
                           </a:solidFill>
                           <a:latin typeface="Arial"/>
                         </a:rPr>
-                        <a:t>Людей писало</a:t>
+                        <a:t>Новых диалогов</a:t>
                       </a:r>
                     </a:p>
                   </a:txBody>
@@ -3922,7 +3922,7 @@
                   </a:tcPr>
                 </a:tc>
               </a:tr>
-              <a:tr h="325858">
+              <a:tr h="716889">
                 <a:tc>
                   <a:txBody>
                     <a:bodyPr wrap="square" anchor="ctr"/>
@@ -3936,241 +3936,7 @@
                           </a:solidFill>
                           <a:latin typeface="Arial"/>
                         </a:rPr>
-                        <a:t>02.07</a:t>
-                      </a:r>
-                    </a:p>
-                  </a:txBody>
-                  <a:tcPr marL="45720" marR="45720" marT="18288" marB="18288">
-                    <a:solidFill>
-                      <a:srgbClr val="FFFFFF"/>
-                    </a:solidFill>
-                  </a:tcPr>
-                </a:tc>
-                <a:tc>
-                  <a:txBody>
-                    <a:bodyPr wrap="square" anchor="ctr"/>
-                    <a:lstStyle/>
-                    <a:p>
-                      <a:pPr algn="ctr"/>
-                      <a:r>
-                        <a:rPr sz="1150" b="0" i="0">
-                          <a:solidFill>
-                            <a:srgbClr val="15243D"/>
-                          </a:solidFill>
-                          <a:latin typeface="Arial"/>
-                        </a:rPr>
-                        <a:t>117</a:t>
-                      </a:r>
-                    </a:p>
-                  </a:txBody>
-                  <a:tcPr marL="45720" marR="45720" marT="18288" marB="18288">
-                    <a:solidFill>
-                      <a:srgbClr val="FFFFFF"/>
-                    </a:solidFill>
-                  </a:tcPr>
-                </a:tc>
-                <a:tc>
-                  <a:txBody>
-                    <a:bodyPr wrap="square" anchor="ctr"/>
-                    <a:lstStyle/>
-                    <a:p>
-                      <a:pPr algn="ctr"/>
-                      <a:r>
-                        <a:rPr sz="1150" b="0" i="0">
-                          <a:solidFill>
-                            <a:srgbClr val="15243D"/>
-                          </a:solidFill>
-                          <a:latin typeface="Arial"/>
-                        </a:rPr>
-                        <a:t>1058</a:t>
-                      </a:r>
-                    </a:p>
-                  </a:txBody>
-                  <a:tcPr marL="45720" marR="45720" marT="18288" marB="18288">
-                    <a:solidFill>
-                      <a:srgbClr val="FFFFFF"/>
-                    </a:solidFill>
-                  </a:tcPr>
-                </a:tc>
-                <a:tc>
-                  <a:txBody>
-                    <a:bodyPr wrap="square" anchor="ctr"/>
-                    <a:lstStyle/>
-                    <a:p>
-                      <a:pPr algn="ctr"/>
-                      <a:r>
-                        <a:rPr sz="1150" b="0" i="0">
-                          <a:solidFill>
-                            <a:srgbClr val="15243D"/>
-                          </a:solidFill>
-                          <a:latin typeface="Arial"/>
-                        </a:rPr>
-                        <a:t>836</a:t>
-                      </a:r>
-                    </a:p>
-                  </a:txBody>
-                  <a:tcPr marL="45720" marR="45720" marT="18288" marB="18288">
-                    <a:solidFill>
-                      <a:srgbClr val="FFFFFF"/>
-                    </a:solidFill>
-                  </a:tcPr>
-                </a:tc>
-              </a:tr>
-              <a:tr h="325858">
-                <a:tc>
-                  <a:txBody>
-                    <a:bodyPr wrap="square" anchor="ctr"/>
-                    <a:lstStyle/>
-                    <a:p>
-                      <a:pPr algn="ctr"/>
-                      <a:r>
-                        <a:rPr sz="1150" b="0" i="0">
-                          <a:solidFill>
-                            <a:srgbClr val="15243D"/>
-                          </a:solidFill>
-                          <a:latin typeface="Arial"/>
-                        </a:rPr>
-                        <a:t>01.07</a:t>
-                      </a:r>
-                    </a:p>
-                  </a:txBody>
-                  <a:tcPr marL="45720" marR="45720" marT="18288" marB="18288">
-                    <a:solidFill>
-                      <a:srgbClr val="EEF2F6"/>
-                    </a:solidFill>
-                  </a:tcPr>
-                </a:tc>
-                <a:tc>
-                  <a:txBody>
-                    <a:bodyPr wrap="square" anchor="ctr"/>
-                    <a:lstStyle/>
-                    <a:p>
-                      <a:pPr algn="ctr"/>
-                      <a:r>
-                        <a:rPr sz="1150" b="0" i="0">
-                          <a:solidFill>
-                            <a:srgbClr val="15243D"/>
-                          </a:solidFill>
-                          <a:latin typeface="Arial"/>
-                        </a:rPr>
-                        <a:t>72</a:t>
-                      </a:r>
-                    </a:p>
-                  </a:txBody>
-                  <a:tcPr marL="45720" marR="45720" marT="18288" marB="18288">
-                    <a:solidFill>
-                      <a:srgbClr val="EEF2F6"/>
-                    </a:solidFill>
-                  </a:tcPr>
-                </a:tc>
-                <a:tc>
-                  <a:txBody>
-                    <a:bodyPr wrap="square" anchor="ctr"/>
-                    <a:lstStyle/>
-                    <a:p>
-                      <a:pPr algn="ctr"/>
-                      <a:r>
-                        <a:rPr sz="1150" b="0" i="0">
-                          <a:solidFill>
-                            <a:srgbClr val="15243D"/>
-                          </a:solidFill>
-                          <a:latin typeface="Arial"/>
-                        </a:rPr>
-                        <a:t>348</a:t>
-                      </a:r>
-                    </a:p>
-                  </a:txBody>
-                  <a:tcPr marL="45720" marR="45720" marT="18288" marB="18288">
-                    <a:solidFill>
-                      <a:srgbClr val="EEF2F6"/>
-                    </a:solidFill>
-                  </a:tcPr>
-                </a:tc>
-                <a:tc>
-                  <a:txBody>
-                    <a:bodyPr wrap="square" anchor="ctr"/>
-                    <a:lstStyle/>
-                    <a:p>
-                      <a:pPr algn="ctr"/>
-                      <a:r>
-                        <a:rPr sz="1150" b="0" i="0">
-                          <a:solidFill>
-                            <a:srgbClr val="15243D"/>
-                          </a:solidFill>
-                          <a:latin typeface="Arial"/>
-                        </a:rPr>
-                        <a:t>191</a:t>
-                      </a:r>
-                    </a:p>
-                  </a:txBody>
-                  <a:tcPr marL="45720" marR="45720" marT="18288" marB="18288">
-                    <a:solidFill>
-                      <a:srgbClr val="EEF2F6"/>
-                    </a:solidFill>
-                  </a:tcPr>
-                </a:tc>
-              </a:tr>
-              <a:tr h="325858">
-                <a:tc>
-                  <a:txBody>
-                    <a:bodyPr wrap="square" anchor="ctr"/>
-                    <a:lstStyle/>
-                    <a:p>
-                      <a:pPr algn="ctr"/>
-                      <a:r>
-                        <a:rPr sz="1150" b="0" i="0">
-                          <a:solidFill>
-                            <a:srgbClr val="15243D"/>
-                          </a:solidFill>
-                          <a:latin typeface="Arial"/>
-                        </a:rPr>
-                        <a:t>30.06</a:t>
-                      </a:r>
-                    </a:p>
-                  </a:txBody>
-                  <a:tcPr marL="45720" marR="45720" marT="18288" marB="18288">
-                    <a:solidFill>
-                      <a:srgbClr val="FFFFFF"/>
-                    </a:solidFill>
-                  </a:tcPr>
-                </a:tc>
-                <a:tc>
-                  <a:txBody>
-                    <a:bodyPr wrap="square" anchor="ctr"/>
-                    <a:lstStyle/>
-                    <a:p>
-                      <a:pPr algn="ctr"/>
-                      <a:r>
-                        <a:rPr sz="1150" b="0" i="0">
-                          <a:solidFill>
-                            <a:srgbClr val="15243D"/>
-                          </a:solidFill>
-                          <a:latin typeface="Arial"/>
-                        </a:rPr>
-                        <a:t>73</a:t>
-                      </a:r>
-                    </a:p>
-                  </a:txBody>
-                  <a:tcPr marL="45720" marR="45720" marT="18288" marB="18288">
-                    <a:solidFill>
-                      <a:srgbClr val="FFFFFF"/>
-                    </a:solidFill>
-                  </a:tcPr>
-                </a:tc>
-                <a:tc>
-                  <a:txBody>
-                    <a:bodyPr wrap="square" anchor="ctr"/>
-                    <a:lstStyle/>
-                    <a:p>
-                      <a:pPr algn="ctr"/>
-                      <a:r>
-                        <a:rPr sz="1150" b="0" i="0">
-                          <a:solidFill>
-                            <a:srgbClr val="15243D"/>
-                          </a:solidFill>
-                          <a:latin typeface="Arial"/>
-                        </a:rPr>
-                        <a:t>261</a:t>
+                        <a:t>03.07</a:t>
                       </a:r>
                     </a:p>
                   </a:txBody>
@@ -4203,8 +3969,6 @@
                     </a:solidFill>
                   </a:tcPr>
                 </a:tc>
-              </a:tr>
-              <a:tr h="325858">
                 <a:tc>
                   <a:txBody>
                     <a:bodyPr wrap="square" anchor="ctr"/>
@@ -4218,7 +3982,55 @@
                           </a:solidFill>
                           <a:latin typeface="Arial"/>
                         </a:rPr>
-                        <a:t>29.06</a:t>
+                        <a:t>581</a:t>
+                      </a:r>
+                    </a:p>
+                  </a:txBody>
+                  <a:tcPr marL="45720" marR="45720" marT="18288" marB="18288">
+                    <a:solidFill>
+                      <a:srgbClr val="FFFFFF"/>
+                    </a:solidFill>
+                  </a:tcPr>
+                </a:tc>
+                <a:tc>
+                  <a:txBody>
+                    <a:bodyPr wrap="square" anchor="ctr"/>
+                    <a:lstStyle/>
+                    <a:p>
+                      <a:pPr algn="ctr"/>
+                      <a:r>
+                        <a:rPr sz="1150" b="0" i="0">
+                          <a:solidFill>
+                            <a:srgbClr val="15243D"/>
+                          </a:solidFill>
+                          <a:latin typeface="Arial"/>
+                        </a:rPr>
+                        <a:t>487</a:t>
+                      </a:r>
+                    </a:p>
+                  </a:txBody>
+                  <a:tcPr marL="45720" marR="45720" marT="18288" marB="18288">
+                    <a:solidFill>
+                      <a:srgbClr val="FFFFFF"/>
+                    </a:solidFill>
+                  </a:tcPr>
+                </a:tc>
+              </a:tr>
+              <a:tr h="716889">
+                <a:tc>
+                  <a:txBody>
+                    <a:bodyPr wrap="square" anchor="ctr"/>
+                    <a:lstStyle/>
+                    <a:p>
+                      <a:pPr algn="ctr"/>
+                      <a:r>
+                        <a:rPr sz="1150" b="0" i="0">
+                          <a:solidFill>
+                            <a:srgbClr val="15243D"/>
+                          </a:solidFill>
+                          <a:latin typeface="Arial"/>
+                        </a:rPr>
+                        <a:t>02.07</a:t>
                       </a:r>
                     </a:p>
                   </a:txBody>
@@ -4241,7 +4053,7 @@
                           </a:solidFill>
                           <a:latin typeface="Arial"/>
                         </a:rPr>
-                        <a:t>78</a:t>
+                        <a:t>100</a:t>
                       </a:r>
                     </a:p>
                   </a:txBody>
@@ -4264,7 +4076,7 @@
                           </a:solidFill>
                           <a:latin typeface="Arial"/>
                         </a:rPr>
-                        <a:t>287</a:t>
+                        <a:t>981</a:t>
                       </a:r>
                     </a:p>
                   </a:txBody>
@@ -4287,7 +4099,7 @@
                           </a:solidFill>
                           <a:latin typeface="Arial"/>
                         </a:rPr>
-                        <a:t>0</a:t>
+                        <a:t>776</a:t>
                       </a:r>
                     </a:p>
                   </a:txBody>
@@ -4298,7 +4110,7 @@
                   </a:tcPr>
                 </a:tc>
               </a:tr>
-              <a:tr h="325858">
+              <a:tr h="716889">
                 <a:tc>
                   <a:txBody>
                     <a:bodyPr wrap="square" anchor="ctr"/>
@@ -4312,7 +4124,7 @@
                           </a:solidFill>
                           <a:latin typeface="Arial"/>
                         </a:rPr>
-                        <a:t>28.06</a:t>
+                        <a:t>01.07</a:t>
                       </a:r>
                     </a:p>
                   </a:txBody>
@@ -4335,7 +4147,7 @@
                           </a:solidFill>
                           <a:latin typeface="Arial"/>
                         </a:rPr>
-                        <a:t>61</a:t>
+                        <a:t>48</a:t>
                       </a:r>
                     </a:p>
                   </a:txBody>
@@ -4358,7 +4170,7 @@
                           </a:solidFill>
                           <a:latin typeface="Arial"/>
                         </a:rPr>
-                        <a:t>185</a:t>
+                        <a:t>244</a:t>
                       </a:r>
                     </a:p>
                   </a:txBody>
@@ -4381,7 +4193,7 @@
                           </a:solidFill>
                           <a:latin typeface="Arial"/>
                         </a:rPr>
-                        <a:t>0</a:t>
+                        <a:t>137</a:t>
                       </a:r>
                     </a:p>
                   </a:txBody>
@@ -4392,383 +4204,7 @@
                   </a:tcPr>
                 </a:tc>
               </a:tr>
-              <a:tr h="325858">
-                <a:tc>
-                  <a:txBody>
-                    <a:bodyPr wrap="square" anchor="ctr"/>
-                    <a:lstStyle/>
-                    <a:p>
-                      <a:pPr algn="ctr"/>
-                      <a:r>
-                        <a:rPr sz="1150" b="0" i="0">
-                          <a:solidFill>
-                            <a:srgbClr val="15243D"/>
-                          </a:solidFill>
-                          <a:latin typeface="Arial"/>
-                        </a:rPr>
-                        <a:t>27.06</a:t>
-                      </a:r>
-                    </a:p>
-                  </a:txBody>
-                  <a:tcPr marL="45720" marR="45720" marT="18288" marB="18288">
-                    <a:solidFill>
-                      <a:srgbClr val="EEF2F6"/>
-                    </a:solidFill>
-                  </a:tcPr>
-                </a:tc>
-                <a:tc>
-                  <a:txBody>
-                    <a:bodyPr wrap="square" anchor="ctr"/>
-                    <a:lstStyle/>
-                    <a:p>
-                      <a:pPr algn="ctr"/>
-                      <a:r>
-                        <a:rPr sz="1150" b="0" i="0">
-                          <a:solidFill>
-                            <a:srgbClr val="15243D"/>
-                          </a:solidFill>
-                          <a:latin typeface="Arial"/>
-                        </a:rPr>
-                        <a:t>71</a:t>
-                      </a:r>
-                    </a:p>
-                  </a:txBody>
-                  <a:tcPr marL="45720" marR="45720" marT="18288" marB="18288">
-                    <a:solidFill>
-                      <a:srgbClr val="EEF2F6"/>
-                    </a:solidFill>
-                  </a:tcPr>
-                </a:tc>
-                <a:tc>
-                  <a:txBody>
-                    <a:bodyPr wrap="square" anchor="ctr"/>
-                    <a:lstStyle/>
-                    <a:p>
-                      <a:pPr algn="ctr"/>
-                      <a:r>
-                        <a:rPr sz="1150" b="0" i="0">
-                          <a:solidFill>
-                            <a:srgbClr val="15243D"/>
-                          </a:solidFill>
-                          <a:latin typeface="Arial"/>
-                        </a:rPr>
-                        <a:t>181</a:t>
-                      </a:r>
-                    </a:p>
-                  </a:txBody>
-                  <a:tcPr marL="45720" marR="45720" marT="18288" marB="18288">
-                    <a:solidFill>
-                      <a:srgbClr val="EEF2F6"/>
-                    </a:solidFill>
-                  </a:tcPr>
-                </a:tc>
-                <a:tc>
-                  <a:txBody>
-                    <a:bodyPr wrap="square" anchor="ctr"/>
-                    <a:lstStyle/>
-                    <a:p>
-                      <a:pPr algn="ctr"/>
-                      <a:r>
-                        <a:rPr sz="1150" b="0" i="0">
-                          <a:solidFill>
-                            <a:srgbClr val="15243D"/>
-                          </a:solidFill>
-                          <a:latin typeface="Arial"/>
-                        </a:rPr>
-                        <a:t>23</a:t>
-                      </a:r>
-                    </a:p>
-                  </a:txBody>
-                  <a:tcPr marL="45720" marR="45720" marT="18288" marB="18288">
-                    <a:solidFill>
-                      <a:srgbClr val="EEF2F6"/>
-                    </a:solidFill>
-                  </a:tcPr>
-                </a:tc>
-              </a:tr>
-              <a:tr h="325858">
-                <a:tc>
-                  <a:txBody>
-                    <a:bodyPr wrap="square" anchor="ctr"/>
-                    <a:lstStyle/>
-                    <a:p>
-                      <a:pPr algn="ctr"/>
-                      <a:r>
-                        <a:rPr sz="1150" b="0" i="0">
-                          <a:solidFill>
-                            <a:srgbClr val="15243D"/>
-                          </a:solidFill>
-                          <a:latin typeface="Arial"/>
-                        </a:rPr>
-                        <a:t>26.06</a:t>
-                      </a:r>
-                    </a:p>
-                  </a:txBody>
-                  <a:tcPr marL="45720" marR="45720" marT="18288" marB="18288">
-                    <a:solidFill>
-                      <a:srgbClr val="FFFFFF"/>
-                    </a:solidFill>
-                  </a:tcPr>
-                </a:tc>
-                <a:tc>
-                  <a:txBody>
-                    <a:bodyPr wrap="square" anchor="ctr"/>
-                    <a:lstStyle/>
-                    <a:p>
-                      <a:pPr algn="ctr"/>
-                      <a:r>
-                        <a:rPr sz="1150" b="0" i="0">
-                          <a:solidFill>
-                            <a:srgbClr val="15243D"/>
-                          </a:solidFill>
-                          <a:latin typeface="Arial"/>
-                        </a:rPr>
-                        <a:t>71</a:t>
-                      </a:r>
-                    </a:p>
-                  </a:txBody>
-                  <a:tcPr marL="45720" marR="45720" marT="18288" marB="18288">
-                    <a:solidFill>
-                      <a:srgbClr val="FFFFFF"/>
-                    </a:solidFill>
-                  </a:tcPr>
-                </a:tc>
-                <a:tc>
-                  <a:txBody>
-                    <a:bodyPr wrap="square" anchor="ctr"/>
-                    <a:lstStyle/>
-                    <a:p>
-                      <a:pPr algn="ctr"/>
-                      <a:r>
-                        <a:rPr sz="1150" b="0" i="0">
-                          <a:solidFill>
-                            <a:srgbClr val="15243D"/>
-                          </a:solidFill>
-                          <a:latin typeface="Arial"/>
-                        </a:rPr>
-                        <a:t>262</a:t>
-                      </a:r>
-                    </a:p>
-                  </a:txBody>
-                  <a:tcPr marL="45720" marR="45720" marT="18288" marB="18288">
-                    <a:solidFill>
-                      <a:srgbClr val="FFFFFF"/>
-                    </a:solidFill>
-                  </a:tcPr>
-                </a:tc>
-                <a:tc>
-                  <a:txBody>
-                    <a:bodyPr wrap="square" anchor="ctr"/>
-                    <a:lstStyle/>
-                    <a:p>
-                      <a:pPr algn="ctr"/>
-                      <a:r>
-                        <a:rPr sz="1150" b="0" i="0">
-                          <a:solidFill>
-                            <a:srgbClr val="15243D"/>
-                          </a:solidFill>
-                          <a:latin typeface="Arial"/>
-                        </a:rPr>
-                        <a:t>0</a:t>
-                      </a:r>
-                    </a:p>
-                  </a:txBody>
-                  <a:tcPr marL="45720" marR="45720" marT="18288" marB="18288">
-                    <a:solidFill>
-                      <a:srgbClr val="FFFFFF"/>
-                    </a:solidFill>
-                  </a:tcPr>
-                </a:tc>
-              </a:tr>
-              <a:tr h="325858">
-                <a:tc>
-                  <a:txBody>
-                    <a:bodyPr wrap="square" anchor="ctr"/>
-                    <a:lstStyle/>
-                    <a:p>
-                      <a:pPr algn="ctr"/>
-                      <a:r>
-                        <a:rPr sz="1150" b="0" i="0">
-                          <a:solidFill>
-                            <a:srgbClr val="15243D"/>
-                          </a:solidFill>
-                          <a:latin typeface="Arial"/>
-                        </a:rPr>
-                        <a:t>25.06</a:t>
-                      </a:r>
-                    </a:p>
-                  </a:txBody>
-                  <a:tcPr marL="45720" marR="45720" marT="18288" marB="18288">
-                    <a:solidFill>
-                      <a:srgbClr val="EEF2F6"/>
-                    </a:solidFill>
-                  </a:tcPr>
-                </a:tc>
-                <a:tc>
-                  <a:txBody>
-                    <a:bodyPr wrap="square" anchor="ctr"/>
-                    <a:lstStyle/>
-                    <a:p>
-                      <a:pPr algn="ctr"/>
-                      <a:r>
-                        <a:rPr sz="1150" b="0" i="0">
-                          <a:solidFill>
-                            <a:srgbClr val="15243D"/>
-                          </a:solidFill>
-                          <a:latin typeface="Arial"/>
-                        </a:rPr>
-                        <a:t>48</a:t>
-                      </a:r>
-                    </a:p>
-                  </a:txBody>
-                  <a:tcPr marL="45720" marR="45720" marT="18288" marB="18288">
-                    <a:solidFill>
-                      <a:srgbClr val="EEF2F6"/>
-                    </a:solidFill>
-                  </a:tcPr>
-                </a:tc>
-                <a:tc>
-                  <a:txBody>
-                    <a:bodyPr wrap="square" anchor="ctr"/>
-                    <a:lstStyle/>
-                    <a:p>
-                      <a:pPr algn="ctr"/>
-                      <a:r>
-                        <a:rPr sz="1150" b="0" i="0">
-                          <a:solidFill>
-                            <a:srgbClr val="15243D"/>
-                          </a:solidFill>
-                          <a:latin typeface="Arial"/>
-                        </a:rPr>
-                        <a:t>185</a:t>
-                      </a:r>
-                    </a:p>
-                  </a:txBody>
-                  <a:tcPr marL="45720" marR="45720" marT="18288" marB="18288">
-                    <a:solidFill>
-                      <a:srgbClr val="EEF2F6"/>
-                    </a:solidFill>
-                  </a:tcPr>
-                </a:tc>
-                <a:tc>
-                  <a:txBody>
-                    <a:bodyPr wrap="square" anchor="ctr"/>
-                    <a:lstStyle/>
-                    <a:p>
-                      <a:pPr algn="ctr"/>
-                      <a:r>
-                        <a:rPr sz="1150" b="0" i="0">
-                          <a:solidFill>
-                            <a:srgbClr val="15243D"/>
-                          </a:solidFill>
-                          <a:latin typeface="Arial"/>
-                        </a:rPr>
-                        <a:t>0</a:t>
-                      </a:r>
-                    </a:p>
-                  </a:txBody>
-                  <a:tcPr marL="45720" marR="45720" marT="18288" marB="18288">
-                    <a:solidFill>
-                      <a:srgbClr val="EEF2F6"/>
-                    </a:solidFill>
-                  </a:tcPr>
-                </a:tc>
-              </a:tr>
-              <a:tr h="325858">
-                <a:tc>
-                  <a:txBody>
-                    <a:bodyPr wrap="square" anchor="ctr"/>
-                    <a:lstStyle/>
-                    <a:p>
-                      <a:pPr algn="ctr"/>
-                      <a:r>
-                        <a:rPr sz="1150" b="0" i="0">
-                          <a:solidFill>
-                            <a:srgbClr val="15243D"/>
-                          </a:solidFill>
-                          <a:latin typeface="Arial"/>
-                        </a:rPr>
-                        <a:t>24.06</a:t>
-                      </a:r>
-                    </a:p>
-                  </a:txBody>
-                  <a:tcPr marL="45720" marR="45720" marT="18288" marB="18288">
-                    <a:solidFill>
-                      <a:srgbClr val="FFFFFF"/>
-                    </a:solidFill>
-                  </a:tcPr>
-                </a:tc>
-                <a:tc>
-                  <a:txBody>
-                    <a:bodyPr wrap="square" anchor="ctr"/>
-                    <a:lstStyle/>
-                    <a:p>
-                      <a:pPr algn="ctr"/>
-                      <a:r>
-                        <a:rPr sz="1150" b="0" i="0">
-                          <a:solidFill>
-                            <a:srgbClr val="15243D"/>
-                          </a:solidFill>
-                          <a:latin typeface="Arial"/>
-                        </a:rPr>
-                        <a:t>32</a:t>
-                      </a:r>
-                    </a:p>
-                  </a:txBody>
-                  <a:tcPr marL="45720" marR="45720" marT="18288" marB="18288">
-                    <a:solidFill>
-                      <a:srgbClr val="FFFFFF"/>
-                    </a:solidFill>
-                  </a:tcPr>
-                </a:tc>
-                <a:tc>
-                  <a:txBody>
-                    <a:bodyPr wrap="square" anchor="ctr"/>
-                    <a:lstStyle/>
-                    <a:p>
-                      <a:pPr algn="ctr"/>
-                      <a:r>
-                        <a:rPr sz="1150" b="0" i="0">
-                          <a:solidFill>
-                            <a:srgbClr val="15243D"/>
-                          </a:solidFill>
-                          <a:latin typeface="Arial"/>
-                        </a:rPr>
-                        <a:t>138</a:t>
-                      </a:r>
-                    </a:p>
-                  </a:txBody>
-                  <a:tcPr marL="45720" marR="45720" marT="18288" marB="18288">
-                    <a:solidFill>
-                      <a:srgbClr val="FFFFFF"/>
-                    </a:solidFill>
-                  </a:tcPr>
-                </a:tc>
-                <a:tc>
-                  <a:txBody>
-                    <a:bodyPr wrap="square" anchor="ctr"/>
-                    <a:lstStyle/>
-                    <a:p>
-                      <a:pPr algn="ctr"/>
-                      <a:r>
-                        <a:rPr sz="1150" b="0" i="0">
-                          <a:solidFill>
-                            <a:srgbClr val="15243D"/>
-                          </a:solidFill>
-                          <a:latin typeface="Arial"/>
-                        </a:rPr>
-                        <a:t>77</a:t>
-                      </a:r>
-                    </a:p>
-                  </a:txBody>
-                  <a:tcPr marL="45720" marR="45720" marT="18288" marB="18288">
-                    <a:solidFill>
-                      <a:srgbClr val="FFFFFF"/>
-                    </a:solidFill>
-                  </a:tcPr>
-                </a:tc>
-              </a:tr>
-              <a:tr h="325868">
+              <a:tr h="716892">
                 <a:tc>
                   <a:txBody>
                     <a:bodyPr wrap="square" anchor="ctr"/>
@@ -4805,7 +4241,7 @@
                           </a:solidFill>
                           <a:latin typeface="Arial"/>
                         </a:rPr>
-                        <a:t>503 человека</a:t>
+                        <a:t>230 диалогов</a:t>
                       </a:r>
                     </a:p>
                   </a:txBody>
@@ -4828,7 +4264,7 @@
                           </a:solidFill>
                           <a:latin typeface="Arial"/>
                         </a:rPr>
-                        <a:t>2911</a:t>
+                        <a:t>1806</a:t>
                       </a:r>
                     </a:p>
                   </a:txBody>
@@ -4851,7 +4287,7 @@
                           </a:solidFill>
                           <a:latin typeface="Arial"/>
                         </a:rPr>
-                        <a:t>1215 ответов бота</a:t>
+                        <a:t>1400 ответов бота</a:t>
                       </a:r>
                     </a:p>
                   </a:txBody>
@@ -4893,7 +4329,7 @@
                 </a:solidFill>
                 <a:latin typeface="Arial"/>
               </a:rPr>
-              <a:t>25–29 июня бот был выключен (ответов 0) — люди писали, но автоответа не было. Это упущенные обращения.</a:t>
+              <a:t>Бот в боевом режиме с 1 июля — отвечает 24/7, почти половина обращений приходит вне рабочих часов.</a:t>
             </a:r>
           </a:p>
         </p:txBody>
@@ -5168,7 +4604,7 @@
                 </a:solidFill>
                 <a:latin typeface="Arial"/>
               </a:rPr>
-              <a:t>503</a:t>
+              <a:t>230</a:t>
             </a:r>
           </a:p>
         </p:txBody>
@@ -5200,7 +4636,7 @@
                 </a:solidFill>
                 <a:latin typeface="Arial"/>
               </a:rPr>
-              <a:t>человека написали</a:t>
+              <a:t>диалога</a:t>
             </a:r>
           </a:p>
           <a:p>
@@ -5211,7 +4647,7 @@
                 </a:solidFill>
                 <a:latin typeface="Arial"/>
               </a:rPr>
-              <a:t>35–100 новых/день</a:t>
+              <a:t>48–100 новых/день</a:t>
             </a:r>
           </a:p>
         </p:txBody>
@@ -5288,7 +4724,7 @@
                 </a:solidFill>
                 <a:latin typeface="Arial"/>
               </a:rPr>
-              <a:t>4122</a:t>
+              <a:t>3200</a:t>
             </a:r>
           </a:p>
         </p:txBody>
@@ -5320,7 +4756,7 @@
                 </a:solidFill>
                 <a:latin typeface="Arial"/>
               </a:rPr>
-              <a:t>сообщения</a:t>
+              <a:t>сообщений</a:t>
             </a:r>
           </a:p>
           <a:p>
@@ -5408,7 +4844,7 @@
                 </a:solidFill>
                 <a:latin typeface="Arial"/>
               </a:rPr>
-              <a:t>1209</a:t>
+              <a:t>1400</a:t>
             </a:r>
           </a:p>
         </p:txBody>
@@ -5528,7 +4964,7 @@
                 </a:solidFill>
                 <a:latin typeface="Arial"/>
               </a:rPr>
-              <a:t>98,4%</a:t>
+              <a:t>70%</a:t>
             </a:r>
           </a:p>
         </p:txBody>
@@ -5648,7 +5084,7 @@
                 </a:solidFill>
                 <a:latin typeface="Arial"/>
               </a:rPr>
-              <a:t>Туры 338 · визы 176</a:t>
+              <a:t>Туры 131 · визы 99</a:t>
             </a:r>
           </a:p>
         </p:txBody>
@@ -5848,7 +5284,7 @@
                 </a:solidFill>
                 <a:latin typeface="Arial"/>
               </a:rPr>
-              <a:t>ГРАДАЦИЯ ВОВЛЕЧЁННОСТИ</a:t>
+              <a:t>ТРИАЖ ЛИДОВ — УЖЕ РАБОТАЕТ</a:t>
             </a:r>
           </a:p>
         </p:txBody>
@@ -5880,7 +5316,7 @@
                 </a:solidFill>
                 <a:latin typeface="Arial"/>
               </a:rPr>
-              <a:t>Честно: сколько из них реальные, а не случайные</a:t>
+              <a:t>Бот сам делит поток: где деньги, а где шум</a:t>
             </a:r>
           </a:p>
         </p:txBody>
@@ -6000,7 +5436,7 @@
                 </a:solidFill>
                 <a:latin typeface="Arial"/>
               </a:rPr>
-              <a:t>503</a:t>
+              <a:t>230</a:t>
             </a:r>
           </a:p>
         </p:txBody>
@@ -6032,7 +5468,7 @@
                 </a:solidFill>
                 <a:latin typeface="Arial"/>
               </a:rPr>
-              <a:t>написали хоть раз</a:t>
+              <a:t>весь поток за 1-3 июля</a:t>
             </a:r>
           </a:p>
           <a:p>
@@ -6043,7 +5479,7 @@
                 </a:solidFill>
                 <a:latin typeface="Arial"/>
               </a:rPr>
-              <a:t>весь поток, включая «спросил и ушёл»</a:t>
+              <a:t>все, кто написал</a:t>
             </a:r>
           </a:p>
         </p:txBody>
@@ -6120,7 +5556,7 @@
                 </a:solidFill>
                 <a:latin typeface="Arial"/>
               </a:rPr>
-              <a:t>332</a:t>
+              <a:t>160</a:t>
             </a:r>
           </a:p>
         </p:txBody>
@@ -6152,7 +5588,7 @@
                 </a:solidFill>
                 <a:latin typeface="Arial"/>
               </a:rPr>
-              <a:t>реальный диалог</a:t>
+              <a:t>бот довёл сам</a:t>
             </a:r>
           </a:p>
           <a:p>
@@ -6163,7 +5599,7 @@
                 </a:solidFill>
                 <a:latin typeface="Arial"/>
               </a:rPr>
-              <a:t>2+ сообщения — реально пообщались с ботом</a:t>
+              <a:t>без передачи менеджеру (70%)</a:t>
             </a:r>
           </a:p>
         </p:txBody>
@@ -6240,7 +5676,7 @@
                 </a:solidFill>
                 <a:latin typeface="Arial"/>
               </a:rPr>
-              <a:t>232</a:t>
+              <a:t>74</a:t>
             </a:r>
           </a:p>
         </p:txBody>
@@ -6272,7 +5708,7 @@
                 </a:solidFill>
                 <a:latin typeface="Arial"/>
               </a:rPr>
-              <a:t>вовлечённые</a:t>
+              <a:t>готовы платить</a:t>
             </a:r>
           </a:p>
           <a:p>
@@ -6283,7 +5719,7 @@
                 </a:solidFill>
                 <a:latin typeface="Arial"/>
               </a:rPr>
-              <a:t>4+ сообщения — плотно общались по турам/визам</a:t>
+              <a:t>бот выделил как горячих — им менеджер бегом</a:t>
             </a:r>
           </a:p>
         </p:txBody>
@@ -6316,7 +5752,7 @@
                 </a:solidFill>
                 <a:latin typeface="Arial"/>
               </a:rPr>
-              <a:t>И всё это бот вёл сам, без менеджеров. 503 — это поток, 232 — те, кто реально в разговоре.</a:t>
+              <a:t>Всю разметку бот делает сам, без единой ручной кнопки: 230 — поток, 74 — те, у кого деньги.</a:t>
             </a:r>
           </a:p>
         </p:txBody>
@@ -7065,7 +6501,7 @@
                 </a:solidFill>
                 <a:latin typeface="Arial"/>
               </a:rPr>
-              <a:t>Стало ~$3–6/день</a:t>
+              <a:t>Стало ~$1–2,5/день</a:t>
             </a:r>
           </a:p>
         </p:txBody>
@@ -8989,7 +8425,7 @@
                 </a:solidFill>
                 <a:latin typeface="Arial"/>
               </a:rPr>
-              <a:t>ПРИМЕР МАКЕТА</a:t>
+              <a:t>УЖЕ РАБОТАЕТ НА ПРОДЕ</a:t>
             </a:r>
           </a:p>
         </p:txBody>
@@ -9021,7 +8457,7 @@
                 </a:solidFill>
                 <a:latin typeface="Arial"/>
               </a:rPr>
-              <a:t>Панель владельца</a:t>
+              <a:t>Панель владельца «Покупатели сегодня»</a:t>
             </a:r>
           </a:p>
         </p:txBody>
@@ -9123,7 +8559,7 @@
         <p:spPr>
           <a:xfrm>
             <a:off x="1078992" y="2304288"/>
-            <a:ext cx="2926080" cy="320040"/>
+            <a:ext cx="5669280" cy="320040"/>
           </a:xfrm>
           <a:prstGeom prst="rect">
             <a:avLst/>
@@ -9141,7 +8577,7 @@
                 </a:solidFill>
                 <a:latin typeface="Arial"/>
               </a:rPr>
-              <a:t>Сегодня</a:t>
+              <a:t>Бот уже разметил поток</a:t>
             </a:r>
           </a:p>
         </p:txBody>
@@ -9155,7 +8591,7 @@
         <p:spPr>
           <a:xfrm>
             <a:off x="1078992" y="2743200"/>
-            <a:ext cx="4754880" cy="228600"/>
+            <a:ext cx="6035040" cy="228600"/>
           </a:xfrm>
           <a:prstGeom prst="rect">
             <a:avLst/>
@@ -9173,7 +8609,7 @@
                 </a:solidFill>
                 <a:latin typeface="Arial"/>
               </a:rPr>
-              <a:t>деньги за 5 секунд, а не 100 чатов</a:t>
+              <a:t>деньги за 5 секунд, а не 100 чатов — размечено само</a:t>
             </a:r>
           </a:p>
         </p:txBody>
@@ -9246,11 +8682,11 @@
             <a:r>
               <a:rPr sz="2400" b="1" i="0">
                 <a:solidFill>
-                  <a:srgbClr val="DE4A4D"/>
-                </a:solidFill>
-                <a:latin typeface="Arial"/>
-              </a:rPr>
-              <a:t>12</a:t>
+                  <a:srgbClr val="009C94"/>
+                </a:solidFill>
+                <a:latin typeface="Arial"/>
+              </a:rPr>
+              <a:t>74</a:t>
             </a:r>
           </a:p>
         </p:txBody>
@@ -9282,7 +8718,18 @@
                 </a:solidFill>
                 <a:latin typeface="Arial"/>
               </a:rPr>
-              <a:t>горячих</a:t>
+              <a:t>готовых</a:t>
+            </a:r>
+          </a:p>
+          <a:p>
+            <a:r>
+              <a:rPr sz="1250" b="0" i="0">
+                <a:solidFill>
+                  <a:srgbClr val="FFFFFF"/>
+                </a:solidFill>
+                <a:latin typeface="Arial"/>
+              </a:rPr>
+              <a:t>платить</a:t>
             </a:r>
           </a:p>
         </p:txBody>
@@ -9359,7 +8806,7 @@
                 </a:solidFill>
                 <a:latin typeface="Arial"/>
               </a:rPr>
-              <a:t>40</a:t>
+              <a:t>88</a:t>
             </a:r>
           </a:p>
         </p:txBody>
@@ -9479,7 +8926,7 @@
                 </a:solidFill>
                 <a:latin typeface="Arial"/>
               </a:rPr>
-              <a:t>30</a:t>
+              <a:t>70</a:t>
             </a:r>
           </a:p>
         </p:txBody>
@@ -9511,7 +8958,18 @@
                 </a:solidFill>
                 <a:latin typeface="Arial"/>
               </a:rPr>
-              <a:t>ушли</a:t>
+              <a:t>шум</a:t>
+            </a:r>
+          </a:p>
+          <a:p>
+            <a:r>
+              <a:rPr sz="1250" b="0" i="0">
+                <a:solidFill>
+                  <a:srgbClr val="FFFFFF"/>
+                </a:solidFill>
+                <a:latin typeface="Arial"/>
+              </a:rPr>
+              <a:t>отсеян</a:t>
             </a:r>
           </a:p>
         </p:txBody>
@@ -9584,11 +9042,11 @@
             <a:r>
               <a:rPr sz="2400" b="1" i="0">
                 <a:solidFill>
-                  <a:srgbClr val="009C94"/>
-                </a:solidFill>
-                <a:latin typeface="Arial"/>
-              </a:rPr>
-              <a:t>~сумма</a:t>
+                  <a:srgbClr val="FFFFFF"/>
+                </a:solidFill>
+                <a:latin typeface="Arial"/>
+              </a:rPr>
+              <a:t>сам</a:t>
             </a:r>
           </a:p>
         </p:txBody>
@@ -9620,7 +9078,18 @@
                 </a:solidFill>
                 <a:latin typeface="Arial"/>
               </a:rPr>
-              <a:t>в работе</a:t>
+              <a:t>без ручных</a:t>
+            </a:r>
+          </a:p>
+          <a:p>
+            <a:r>
+              <a:rPr sz="1250" b="0" i="0">
+                <a:solidFill>
+                  <a:srgbClr val="FFFFFF"/>
+                </a:solidFill>
+                <a:latin typeface="Arial"/>
+              </a:rPr>
+              <a:t>кнопок</a:t>
             </a:r>
           </a:p>
         </p:txBody>
@@ -9634,7 +9103,7 @@
         <p:spPr>
           <a:xfrm>
             <a:off x="1078992" y="5010912"/>
-            <a:ext cx="7955279" cy="228600"/>
+            <a:ext cx="9692640" cy="228600"/>
           </a:xfrm>
           <a:prstGeom prst="rect">
             <a:avLst/>
@@ -9652,7 +9121,7 @@
                 </a:solidFill>
                 <a:latin typeface="Arial"/>
               </a:rPr>
-              <a:t>пример макета: менеджеры работают только с деньгами</a:t>
+              <a:t>уже работает: бот сам метит горячих/тёплых/шум и даже исход диалога (оплатил/отказ/пропал)</a:t>
             </a:r>
           </a:p>
         </p:txBody>

</xml_diff>